<commit_message>
feat(results): add PPO DTDE held-out coverage
</commit_message>
<xml_diff>
--- a/submission/presentation.pptx
+++ b/submission/presentation.pptx
@@ -6146,6 +6146,25 @@
                   <a:srgbClr val="1F2A3A"/>
                 </a:solidFill>
               </a:rPr>
+              <a:t>  PPO DTDE: </a:t>
+            </a:r>
+            <a:r>
+              <a:rPr sz="1300" b="1">
+                <a:solidFill>
+                  <a:srgbClr val="1F2A3A"/>
+                </a:solidFill>
+              </a:rPr>
+              <a:t>0.793</a:t>
+            </a:r>
+          </a:p>
+          <a:p>
+            <a:pPr algn="l"/>
+            <a:r>
+              <a:rPr sz="1300">
+                <a:solidFill>
+                  <a:srgbClr val="1F2A3A"/>
+                </a:solidFill>
+              </a:rPr>
               <a:t>  SAC central reward_v2: </a:t>
             </a:r>
             <a:r>
@@ -6253,7 +6272,7 @@
                   <a:srgbClr val="1F2A3A"/>
                 </a:solidFill>
               </a:rPr>
-              <a:t>0.843</a:t>
+              <a:t>0.848</a:t>
             </a:r>
           </a:p>
           <a:p>

</xml_diff>

<commit_message>
fix(results): reconcile cross-split results and CHESCA caveat
</commit_message>
<xml_diff>
--- a/submission/presentation.pptx
+++ b/submission/presentation.pptx
@@ -928,7 +928,7 @@
           <a:lstStyle/>
           <a:p>
             <a:r>
-              <a:t>The headline panel is the held-out phase_2_online_eval split — same 3-building setup as training but weather and demand the agent has never seen. RBC sits at 1.09, PPO central at 0.87, SAC variants cluster at 0.65-0.68. The dashed line at 0.562 is CHESCA's 2023 public-leaderboard score — benchmark context, not a head-to-head number, because CHESCA was scored on the original competition server we cannot re-run.</a:t>
+              <a:t>The headline panel is the held-out phase_2_online_eval split — same 3-building setup as training but weather and demand the agent has never seen. RBC sits at 1.09, PPO central at 0.87, PPO-DTDE at 0.79, and SAC variants cluster at 0.65-0.68. The dashed line at 0.562 is CHESCA's 2023 public-leaderboard score — benchmark context, not a head-to-head number, because CHESCA was scored on the original competition server we cannot re-run.</a:t>
             </a:r>
           </a:p>
           <a:p/>
@@ -6272,7 +6272,7 @@
                   <a:srgbClr val="1F2A3A"/>
                 </a:solidFill>
               </a:rPr>
-              <a:t>0.848</a:t>
+              <a:t>0.843</a:t>
             </a:r>
           </a:p>
           <a:p>

</xml_diff>